<commit_message>
initial code clean up & bug fixing; 04 should run without errors"
</commit_message>
<xml_diff>
--- a/src/01_summarize_updates/data/raw/1. A glimpse of the future - Tier 2 Committee Visions for the future of the agency (2) - Copy.pptx
+++ b/src/01_summarize_updates/data/raw/1. A glimpse of the future - Tier 2 Committee Visions for the future of the agency (2) - Copy.pptx
@@ -172,6 +172,43 @@
   <p188:author id="{98E9ED50-7CF0-AF54-78A3-E0764ACEB75A}" name="Karaganis, Milana (she, her | elle, la) (StatCan)" initials="MK" userId="S::milana.karaganis@statcan.gc.ca::adde4bf7-109b-40ed-ad44-d8d88b4c1092" providerId="AD"/>
   <p188:author id="{A78309A0-1955-EA0D-2F96-7B812CF73310}" name="Martin Chapman" initials="MC" userId="S::martin.chapman@statcan.gc.ca::2305b159-821a-410f-9e22-69ebe8e0cbe8" providerId="AD"/>
 </p188:authorLst>
+</file>
+
+<file path=ppt/revisionInfo.xml><?xml version="1.0" encoding="utf-8"?>
+<p1510:revInfo xmlns:a="http://schemas.openxmlformats.org/drawingml/2006/main" xmlns:r="http://schemas.openxmlformats.org/officeDocument/2006/relationships" xmlns:p1510="http://schemas.microsoft.com/office/powerpoint/2015/10/main">
+  <p1510:revLst>
+    <p1510:client id="{FF6EDEE2-BCD4-4A6F-A375-75593063BBE7}" v="1" dt="2026-05-07T18:42:15.487"/>
+  </p1510:revLst>
+</p1510:revInfo>
+</file>
+
+<file path=ppt/changesInfos/changesInfo1.xml><?xml version="1.0" encoding="utf-8"?>
+<pc:chgInfo xmlns:a="http://schemas.openxmlformats.org/drawingml/2006/main" xmlns:r="http://schemas.openxmlformats.org/officeDocument/2006/relationships" xmlns:ac="http://schemas.microsoft.com/office/drawing/2013/main/command" xmlns:pc="http://schemas.microsoft.com/office/powerpoint/2013/main/command">
+  <pc:docChgLst>
+    <pc:chgData name="Miao, Sophie (StatCan)" userId="611df5aa-9ff2-428f-8c4d-86ee6fcd78d5" providerId="ADAL" clId="{07C2091E-81CF-419D-A41F-973E9B155497}"/>
+    <pc:docChg chg="mod modSld">
+      <pc:chgData name="Miao, Sophie (StatCan)" userId="611df5aa-9ff2-428f-8c4d-86ee6fcd78d5" providerId="ADAL" clId="{07C2091E-81CF-419D-A41F-973E9B155497}" dt="2026-05-07T18:42:26.255" v="1" actId="33475"/>
+      <pc:docMkLst>
+        <pc:docMk/>
+      </pc:docMkLst>
+      <pc:sldChg chg="modSp">
+        <pc:chgData name="Miao, Sophie (StatCan)" userId="611df5aa-9ff2-428f-8c4d-86ee6fcd78d5" providerId="ADAL" clId="{07C2091E-81CF-419D-A41F-973E9B155497}" dt="2026-05-07T18:42:15.477" v="0" actId="20578"/>
+        <pc:sldMkLst>
+          <pc:docMk/>
+          <pc:sldMk cId="371776130" sldId="2147482387"/>
+        </pc:sldMkLst>
+        <pc:graphicFrameChg chg="mod">
+          <ac:chgData name="Miao, Sophie (StatCan)" userId="611df5aa-9ff2-428f-8c4d-86ee6fcd78d5" providerId="ADAL" clId="{07C2091E-81CF-419D-A41F-973E9B155497}" dt="2026-05-07T18:42:15.477" v="0" actId="20578"/>
+          <ac:graphicFrameMkLst>
+            <pc:docMk/>
+            <pc:sldMk cId="371776130" sldId="2147482387"/>
+            <ac:graphicFrameMk id="5" creationId="{C360F1DC-B66C-DE72-4609-328A3706174F}"/>
+          </ac:graphicFrameMkLst>
+        </pc:graphicFrameChg>
+      </pc:sldChg>
+    </pc:docChg>
+  </pc:docChgLst>
+</pc:chgInfo>
 </file>
 
 <file path=ppt/diagrams/colors1.xml><?xml version="1.0" encoding="utf-8"?>
@@ -10110,7 +10147,7 @@
           <a:p>
             <a:fld id="{9F572847-D326-49C9-AF07-20397E2DC730}" type="datetimeFigureOut">
               <a:rPr lang="en-CA" smtClean="0"/>
-              <a:t>2025-09-20</a:t>
+              <a:t>2026-05-07</a:t>
             </a:fld>
             <a:endParaRPr lang="en-CA"/>
           </a:p>
@@ -10277,7 +10314,7 @@
             <a:fld id="{3F5B1DBA-E4F9-4F88-99A6-2D331653C8CB}" type="datetimeFigureOut">
               <a:rPr lang="en-CA" smtClean="0"/>
               <a:pPr/>
-              <a:t>2025-09-20</a:t>
+              <a:t>2026-05-06</a:t>
             </a:fld>
             <a:endParaRPr lang="en-CA"/>
           </a:p>
@@ -13216,7 +13253,7 @@
             <a:fld id="{1D8BD707-D9CF-40AE-B4C6-C98DA3205C09}" type="datetimeFigureOut">
               <a:rPr lang="en-US" smtClean="0"/>
               <a:pPr/>
-              <a:t>9/20/2025</a:t>
+              <a:t>5/6/2026</a:t>
             </a:fld>
             <a:endParaRPr lang="en-US"/>
           </a:p>
@@ -13409,7 +13446,7 @@
           <a:p>
             <a:fld id="{48F494D0-DD41-4D05-9562-9163A910AD62}" type="datetime1">
               <a:rPr lang="en-CA" smtClean="0"/>
-              <a:t>2025-09-20</a:t>
+              <a:t>2026-05-06</a:t>
             </a:fld>
             <a:endParaRPr lang="en-CA"/>
           </a:p>
@@ -13581,7 +13618,7 @@
           <a:p>
             <a:fld id="{BE9A020E-0A37-45D6-BAD3-DCBFF7B564E4}" type="datetime1">
               <a:rPr lang="en-CA" smtClean="0"/>
-              <a:t>2025-09-20</a:t>
+              <a:t>2026-05-06</a:t>
             </a:fld>
             <a:endParaRPr lang="en-CA"/>
           </a:p>
@@ -21496,7 +21533,7 @@
           </a:lstStyle>
           <a:p>
             <a:r>
-              <a:rPr lang="en-CA" sz="2000" b="0" i="0" u="none" strike="noStrike" kern="1200">
+              <a:rPr lang="en-CA" sz="2000" b="0" i="0" u="none" strike="noStrike" kern="1200" dirty="0">
                 <a:latin typeface="+mn-lt"/>
                 <a:ea typeface="+mn-ea"/>
                 <a:cs typeface="+mn-cs"/>
@@ -21504,7 +21541,7 @@
               <a:t>By 2030, Process </a:t>
             </a:r>
             <a:r>
-              <a:rPr lang="en-CA" sz="2000" i="0" u="none" strike="noStrike" kern="1200">
+              <a:rPr lang="en-CA" sz="2000" i="0" u="none" strike="noStrike" kern="1200" dirty="0">
                 <a:latin typeface="+mn-lt"/>
                 <a:ea typeface="+mn-ea"/>
                 <a:cs typeface="+mn-cs"/>
@@ -21512,17 +21549,17 @@
               <a:t>(GSBPM 5.0) will operate infrastructure leveraging AI, ML, and advanced technologies to provide programs with rules for their Data Pipelines. </a:t>
             </a:r>
             <a:r>
-              <a:rPr lang="en-CA" sz="2000"/>
+              <a:rPr lang="en-CA" sz="2000" dirty="0"/>
               <a:t>Resilient, auditable, and adaptive workflows will produce timely, trustworthy, and reproducible statistical outputs across all subject-matter areas. </a:t>
             </a:r>
-            <a:endParaRPr lang="en-CA" sz="2000" i="0" u="none" strike="noStrike" kern="1200">
+            <a:endParaRPr lang="en-CA" sz="2000" i="0" u="none" strike="noStrike" kern="1200" dirty="0">
               <a:latin typeface="+mn-lt"/>
               <a:ea typeface="+mn-ea"/>
               <a:cs typeface="+mn-cs"/>
             </a:endParaRPr>
           </a:p>
           <a:p>
-            <a:endParaRPr lang="en-CA" sz="2000" b="0" i="0" u="none" strike="noStrike" kern="1200">
+            <a:endParaRPr lang="en-CA" sz="2000" b="0" i="0" u="none" strike="noStrike" kern="1200" dirty="0">
               <a:solidFill>
                 <a:schemeClr val="tx1"/>
               </a:solidFill>
@@ -21533,7 +21570,7 @@
           </a:p>
           <a:p>
             <a:r>
-              <a:rPr lang="en-CA" sz="2000" b="1" i="0" u="none" strike="noStrike" kern="1200">
+              <a:rPr lang="en-CA" sz="2000" b="1" i="0" u="none" strike="noStrike" kern="1200" dirty="0">
                 <a:latin typeface="+mn-lt"/>
                 <a:ea typeface="+mn-ea"/>
                 <a:cs typeface="+mn-cs"/>
@@ -21541,17 +21578,17 @@
               <a:t>End-State Vision Statements (Concrete Outcomes):</a:t>
             </a:r>
             <a:r>
-              <a:rPr lang="en-CA" sz="2000" b="1"/>
+              <a:rPr lang="en-CA" sz="2000" b="1" dirty="0"/>
               <a:t> </a:t>
             </a:r>
-            <a:endParaRPr lang="en-CA" sz="1700" i="0" u="none" strike="noStrike" kern="1200">
+            <a:endParaRPr lang="en-CA" sz="1700" i="0" u="none" strike="noStrike" kern="1200" dirty="0">
               <a:latin typeface="+mn-lt"/>
               <a:ea typeface="Calibri"/>
               <a:cs typeface="Calibri"/>
             </a:endParaRPr>
           </a:p>
           <a:p>
-            <a:endParaRPr lang="en-CA" sz="2000" b="1" i="0" u="none" strike="noStrike" kern="1200">
+            <a:endParaRPr lang="en-CA" sz="2000" b="1" i="0" u="none" strike="noStrike" kern="1200" dirty="0">
               <a:solidFill>
                 <a:schemeClr val="tx1"/>
               </a:solidFill>
@@ -21562,7 +21599,7 @@
           </a:p>
           <a:p>
             <a:r>
-              <a:rPr lang="en-CA" sz="1600" b="0" i="0" u="none" strike="noStrike" kern="1200">
+              <a:rPr lang="en-CA" sz="1600" b="0" i="0" u="none" strike="noStrike" kern="1200" dirty="0">
                 <a:latin typeface="+mn-lt"/>
                 <a:ea typeface="+mn-ea"/>
                 <a:cs typeface="+mn-cs"/>
@@ -21570,11 +21607,11 @@
               <a:t>GSBPM 5 sub-processes </a:t>
             </a:r>
             <a:r>
-              <a:rPr lang="en-CA" sz="1600"/>
+              <a:rPr lang="en-CA" sz="1600" dirty="0"/>
               <a:t>are orchestrated</a:t>
             </a:r>
             <a:r>
-              <a:rPr lang="en-CA" sz="1600" b="0" i="0" u="none" strike="noStrike" kern="1200">
+              <a:rPr lang="en-CA" sz="1600" b="0" i="0" u="none" strike="noStrike" kern="1200" dirty="0">
                 <a:latin typeface="+mn-lt"/>
                 <a:ea typeface="+mn-ea"/>
                 <a:cs typeface="+mn-cs"/>
@@ -21582,11 +21619,11 @@
               <a:t> in modular, event-driven </a:t>
             </a:r>
             <a:r>
-              <a:rPr lang="en-CA" sz="1600"/>
+              <a:rPr lang="en-CA" sz="1600" dirty="0"/>
               <a:t>frameworks</a:t>
             </a:r>
             <a:r>
-              <a:rPr lang="en-CA" sz="1600" b="0" i="0" u="none" strike="noStrike" kern="1200">
+              <a:rPr lang="en-CA" sz="1600" b="0" i="0" u="none" strike="noStrike" kern="1200" dirty="0">
                 <a:latin typeface="+mn-lt"/>
                 <a:ea typeface="+mn-ea"/>
                 <a:cs typeface="+mn-cs"/>
@@ -21594,11 +21631,11 @@
               <a:t> that are automated and version-controlled by design.  Analysts are no longer required to manually </a:t>
             </a:r>
             <a:r>
-              <a:rPr lang="en-CA" sz="1600"/>
+              <a:rPr lang="en-CA" sz="1600" dirty="0"/>
               <a:t>intervene, </a:t>
             </a:r>
             <a:r>
-              <a:rPr lang="en-CA" sz="1600" b="0" i="0" u="none" strike="noStrike" kern="1200">
+              <a:rPr lang="en-CA" sz="1600" b="0" i="0" u="none" strike="noStrike" kern="1200" dirty="0">
                 <a:latin typeface="+mn-lt"/>
                 <a:ea typeface="+mn-ea"/>
                 <a:cs typeface="+mn-cs"/>
@@ -21607,7 +21644,7 @@
             </a:r>
           </a:p>
           <a:p>
-            <a:endParaRPr lang="en-CA" sz="1600" b="0" i="0" u="none" strike="noStrike" kern="1200">
+            <a:endParaRPr lang="en-CA" sz="1600" b="0" i="0" u="none" strike="noStrike" kern="1200" dirty="0">
               <a:latin typeface="+mn-lt"/>
               <a:ea typeface="Calibri"/>
               <a:cs typeface="Calibri"/>
@@ -21615,7 +21652,7 @@
           </a:p>
           <a:p>
             <a:r>
-              <a:rPr lang="en-CA" sz="1600" b="0" i="0" u="none" strike="noStrike" kern="1200">
+              <a:rPr lang="en-CA" sz="1600" b="0" i="0" u="none" strike="noStrike" kern="1200" dirty="0">
                 <a:latin typeface="+mn-lt"/>
                 <a:ea typeface="+mn-ea"/>
                 <a:cs typeface="+mn-cs"/>
@@ -21623,11 +21660,11 @@
               <a:t>AI-enabled modules handle 50% </a:t>
             </a:r>
             <a:r>
-              <a:rPr lang="en-CA" sz="1600"/>
+              <a:rPr lang="en-CA" sz="1600" dirty="0"/>
               <a:t>of manual</a:t>
             </a:r>
             <a:r>
-              <a:rPr lang="en-CA" sz="1600" b="0" i="0" u="none" strike="noStrike" kern="1200">
+              <a:rPr lang="en-CA" sz="1600" b="0" i="0" u="none" strike="noStrike" kern="1200" dirty="0">
                 <a:latin typeface="+mn-lt"/>
                 <a:ea typeface="+mn-ea"/>
                 <a:cs typeface="+mn-cs"/>
@@ -21636,7 +21673,7 @@
             </a:r>
           </a:p>
           <a:p>
-            <a:endParaRPr lang="en-CA" sz="1600" b="0" i="0" u="none" strike="noStrike" kern="1200">
+            <a:endParaRPr lang="en-CA" sz="1600" b="0" i="0" u="none" strike="noStrike" kern="1200" dirty="0">
               <a:latin typeface="+mn-lt"/>
               <a:ea typeface="Calibri"/>
               <a:cs typeface="Calibri"/>
@@ -21644,7 +21681,7 @@
           </a:p>
           <a:p>
             <a:r>
-              <a:rPr lang="en-CA" sz="1600" b="0" i="0" u="none" strike="noStrike" kern="1200">
+              <a:rPr lang="en-CA" sz="1600" b="0" i="0" u="none" strike="noStrike" kern="1200" dirty="0">
                 <a:latin typeface="+mn-lt"/>
                 <a:ea typeface="+mn-ea"/>
                 <a:cs typeface="+mn-cs"/>
@@ -21652,7 +21689,7 @@
               <a:t>Every processing pipeline is auditable, reproducible, and deployable across subject-matter domains. </a:t>
             </a:r>
             <a:r>
-              <a:rPr lang="en-CA" sz="1600" b="0" i="0" u="none" kern="1200">
+              <a:rPr lang="en-CA" sz="1600" b="0" i="0" u="none" kern="1200" dirty="0">
                 <a:latin typeface="+mn-lt"/>
                 <a:ea typeface="+mn-ea"/>
                 <a:cs typeface="+mn-cs"/>
@@ -21660,7 +21697,7 @@
               <a:t>Meta-data driven </a:t>
             </a:r>
             <a:r>
-              <a:rPr lang="en-CA" sz="1600" b="0" i="0" u="none" strike="noStrike" kern="1200">
+              <a:rPr lang="en-CA" sz="1600" b="0" i="0" u="none" strike="noStrike" kern="1200" dirty="0">
                 <a:latin typeface="+mn-lt"/>
                 <a:ea typeface="+mn-ea"/>
                 <a:cs typeface="+mn-cs"/>
@@ -21668,12 +21705,12 @@
               <a:t>and standardization </a:t>
             </a:r>
             <a:r>
-              <a:rPr lang="en-CA" sz="1600"/>
+              <a:rPr lang="en-CA" sz="1600" dirty="0"/>
               <a:t>are default by design.</a:t>
             </a:r>
           </a:p>
           <a:p>
-            <a:endParaRPr lang="en-CA" sz="1600" b="0" i="0" u="none" strike="noStrike" kern="1200">
+            <a:endParaRPr lang="en-CA" sz="1600" b="0" i="0" u="none" strike="noStrike" kern="1200" dirty="0">
               <a:latin typeface="+mn-lt"/>
               <a:ea typeface="Calibri"/>
               <a:cs typeface="Calibri"/>
@@ -21681,7 +21718,7 @@
           </a:p>
           <a:p>
             <a:r>
-              <a:rPr lang="en-CA" sz="1600" b="0" i="0" u="none" strike="noStrike" kern="1200">
+              <a:rPr lang="en-CA" sz="1600" b="0" i="0" u="none" strike="noStrike" kern="1200" dirty="0">
                 <a:latin typeface="+mn-lt"/>
                 <a:ea typeface="+mn-ea"/>
                 <a:cs typeface="+mn-cs"/>
@@ -21689,11 +21726,11 @@
               <a:t>Data processing turnaround time </a:t>
             </a:r>
             <a:r>
-              <a:rPr lang="en-CA" sz="1600"/>
+              <a:rPr lang="en-CA" sz="1600" dirty="0"/>
               <a:t>has reduced</a:t>
             </a:r>
             <a:r>
-              <a:rPr lang="en-CA" sz="1600" b="0" i="0" u="none" strike="noStrike" kern="1200">
+              <a:rPr lang="en-CA" sz="1600" b="0" i="0" u="none" strike="noStrike" kern="1200" dirty="0">
                 <a:latin typeface="+mn-lt"/>
                 <a:ea typeface="+mn-ea"/>
                 <a:cs typeface="+mn-cs"/>
@@ -21702,7 +21739,7 @@
             </a:r>
           </a:p>
           <a:p>
-            <a:endParaRPr lang="en-CA" sz="1600" b="0" i="0" u="none" strike="noStrike" kern="1200">
+            <a:endParaRPr lang="en-CA" sz="1600" b="0" i="0" u="none" strike="noStrike" kern="1200" dirty="0">
               <a:latin typeface="+mn-lt"/>
               <a:ea typeface="Calibri"/>
               <a:cs typeface="Calibri"/>
@@ -21710,7 +21747,7 @@
           </a:p>
           <a:p>
             <a:r>
-              <a:rPr lang="en-CA" sz="1600" b="0" i="0" u="none" strike="noStrike" kern="1200">
+              <a:rPr lang="en-CA" sz="1600" b="0" i="0" u="none" strike="noStrike" kern="1200" dirty="0">
                 <a:latin typeface="+mn-lt"/>
                 <a:ea typeface="+mn-ea"/>
                 <a:cs typeface="+mn-cs"/>
@@ -21718,25 +21755,25 @@
               <a:t>Microservices </a:t>
             </a:r>
             <a:r>
-              <a:rPr lang="en-CA" sz="1600"/>
+              <a:rPr lang="en-CA" sz="1600" dirty="0"/>
               <a:t>are used</a:t>
             </a:r>
             <a:r>
-              <a:rPr lang="en-CA" sz="1600" b="0" i="0" u="none" strike="noStrike" kern="1200">
+              <a:rPr lang="en-CA" sz="1600" b="0" i="0" u="none" strike="noStrike" kern="1200" dirty="0">
                 <a:latin typeface="+mn-lt"/>
                 <a:ea typeface="+mn-ea"/>
                 <a:cs typeface="+mn-cs"/>
               </a:rPr>
               <a:t> to manage each processing function (e.g. integrate data, edit, derive new variables, aggregate), with clear input/output standards across surveys and subject-matter areas.</a:t>
             </a:r>
-            <a:endParaRPr lang="en-CA" sz="1600" b="0" i="0" u="none" strike="noStrike" kern="1200">
+            <a:endParaRPr lang="en-CA" sz="1600" b="0" i="0" u="none" strike="noStrike" kern="1200" dirty="0">
               <a:latin typeface="+mn-lt"/>
               <a:ea typeface="Calibri"/>
               <a:cs typeface="Calibri"/>
             </a:endParaRPr>
           </a:p>
           <a:p>
-            <a:endParaRPr lang="en-US" sz="1700">
+            <a:endParaRPr lang="en-US" sz="1700" dirty="0">
               <a:solidFill>
                 <a:schemeClr val="dk1"/>
               </a:solidFill>
@@ -21750,7 +21787,7 @@
                 <a:spcPts val="1200"/>
               </a:spcAft>
             </a:pPr>
-            <a:endParaRPr lang="en-CA" sz="2100">
+            <a:endParaRPr lang="en-CA" sz="2100" dirty="0">
               <a:ea typeface="Calibri" panose="020F0502020204030204"/>
               <a:cs typeface="Calibri" panose="020F0502020204030204"/>
             </a:endParaRPr>
@@ -21761,7 +21798,7 @@
                 <a:spcPts val="1200"/>
               </a:spcAft>
             </a:pPr>
-            <a:endParaRPr lang="en-US" sz="1600">
+            <a:endParaRPr lang="en-US" sz="1600" dirty="0">
               <a:ea typeface="Calibri" panose="020F0502020204030204"/>
               <a:cs typeface="Calibri" panose="020F0502020204030204"/>
             </a:endParaRPr>
@@ -28776,10 +28813,10 @@
             <p:nvPr/>
           </p:nvPicPr>
           <p:blipFill>
-            <a:blip r:embed="rId2">
+            <a:blip>
               <a:extLst>
                 <a:ext uri="{96DAC541-7B7A-43D3-8B79-37D633B846F1}">
-                  <asvg:svgBlip xmlns:asvg="http://schemas.microsoft.com/office/drawing/2016/SVG/main" r:embed="rId3"/>
+                  <asvg:svgBlip xmlns:asvg="http://schemas.microsoft.com/office/drawing/2016/SVG/main" r:embed="rId2"/>
                 </a:ext>
               </a:extLst>
             </a:blip>
@@ -29045,10 +29082,10 @@
             <p:nvPr/>
           </p:nvPicPr>
           <p:blipFill>
-            <a:blip r:embed="rId4">
+            <a:blip>
               <a:extLst>
                 <a:ext uri="{96DAC541-7B7A-43D3-8B79-37D633B846F1}">
-                  <asvg:svgBlip xmlns:asvg="http://schemas.microsoft.com/office/drawing/2016/SVG/main" r:embed="rId5"/>
+                  <asvg:svgBlip xmlns:asvg="http://schemas.microsoft.com/office/drawing/2016/SVG/main" r:embed="rId3"/>
                 </a:ext>
               </a:extLst>
             </a:blip>
@@ -29336,7 +29373,7 @@
             </a:r>
             <a:r>
               <a:rPr lang="en-CA" sz="1400">
-                <a:hlinkClick r:id="rId6"/>
+                <a:hlinkClick r:id="rId4"/>
               </a:rPr>
               <a:t>Standard on Managing Data Analytics Solutions</a:t>
             </a:r>
@@ -29732,10 +29769,10 @@
             <p:nvPr/>
           </p:nvPicPr>
           <p:blipFill>
-            <a:blip r:embed="rId7">
+            <a:blip>
               <a:extLst>
                 <a:ext uri="{96DAC541-7B7A-43D3-8B79-37D633B846F1}">
-                  <asvg:svgBlip xmlns:asvg="http://schemas.microsoft.com/office/drawing/2016/SVG/main" r:embed="rId8"/>
+                  <asvg:svgBlip xmlns:asvg="http://schemas.microsoft.com/office/drawing/2016/SVG/main" r:embed="rId5"/>
                 </a:ext>
               </a:extLst>
             </a:blip>
@@ -30142,10 +30179,10 @@
             <p:nvPr/>
           </p:nvPicPr>
           <p:blipFill>
-            <a:blip r:embed="rId2">
+            <a:blip>
               <a:extLst>
                 <a:ext uri="{96DAC541-7B7A-43D3-8B79-37D633B846F1}">
-                  <asvg:svgBlip xmlns:asvg="http://schemas.microsoft.com/office/drawing/2016/SVG/main" r:embed="rId3"/>
+                  <asvg:svgBlip xmlns:asvg="http://schemas.microsoft.com/office/drawing/2016/SVG/main" r:embed="rId2"/>
                 </a:ext>
               </a:extLst>
             </a:blip>
@@ -30586,10 +30623,10 @@
             <p:nvPr/>
           </p:nvPicPr>
           <p:blipFill>
-            <a:blip r:embed="rId4">
+            <a:blip>
               <a:extLst>
                 <a:ext uri="{96DAC541-7B7A-43D3-8B79-37D633B846F1}">
-                  <asvg:svgBlip xmlns:asvg="http://schemas.microsoft.com/office/drawing/2016/SVG/main" r:embed="rId5"/>
+                  <asvg:svgBlip xmlns:asvg="http://schemas.microsoft.com/office/drawing/2016/SVG/main" r:embed="rId3"/>
                 </a:ext>
               </a:extLst>
             </a:blip>
@@ -30650,7 +30687,7 @@
             </a:r>
             <a:r>
               <a:rPr lang="en-CA" sz="1600">
-                <a:hlinkClick r:id="rId6"/>
+                <a:hlinkClick r:id="rId4"/>
               </a:rPr>
               <a:t>Standard on Managing Data Analytics Solutions</a:t>
             </a:r>
@@ -35185,7 +35222,7 @@
           <p:nvPr>
             <p:extLst>
               <p:ext uri="{D42A27DB-BD31-4B8C-83A1-F6EECF244321}">
-                <p14:modId xmlns:p14="http://schemas.microsoft.com/office/powerpoint/2010/main" val="2824432950"/>
+                <p14:modId xmlns:p14="http://schemas.microsoft.com/office/powerpoint/2010/main" val="1393658281"/>
               </p:ext>
             </p:extLst>
           </p:nvPr>
@@ -35231,7 +35268,7 @@
                     <a:p>
                       <a:pPr algn="ctr"/>
                       <a:r>
-                        <a:rPr lang="en-CA"/>
+                        <a:rPr lang="en-CA" dirty="0"/>
                         <a:t>Vision</a:t>
                       </a:r>
                     </a:p>
@@ -35245,7 +35282,7 @@
                     <a:p>
                       <a:pPr algn="ctr"/>
                       <a:r>
-                        <a:rPr lang="en-CA"/>
+                        <a:rPr lang="en-CA" dirty="0"/>
                         <a:t>Strategic Priorities</a:t>
                       </a:r>
                     </a:p>
@@ -35548,20 +35585,17 @@
                         <a:tabLst/>
                         <a:defRPr/>
                       </a:pPr>
-                      <a:r>
-                        <a:rPr kumimoji="0" lang="en-US" sz="1000" b="0" u="none" strike="noStrike" kern="1200" cap="none" spc="0" normalizeH="0" baseline="0" noProof="0">
-                          <a:ln>
-                            <a:noFill/>
-                          </a:ln>
-                          <a:solidFill>
-                            <a:prstClr val="black"/>
-                          </a:solidFill>
-                          <a:effectLst/>
-                          <a:uLnTx/>
-                          <a:uFillTx/>
-                        </a:rPr>
-                        <a:t>The time and effort involved in designing, rendering and fielding a questionnaire are significantly reduced.</a:t>
-                      </a:r>
+                      <a:endParaRPr kumimoji="0" lang="en-US" sz="1000" b="0" u="none" strike="noStrike" kern="1200" cap="none" spc="0" normalizeH="0" baseline="0" noProof="0" dirty="0">
+                        <a:ln>
+                          <a:noFill/>
+                        </a:ln>
+                        <a:solidFill>
+                          <a:prstClr val="black"/>
+                        </a:solidFill>
+                        <a:effectLst/>
+                        <a:uLnTx/>
+                        <a:uFillTx/>
+                      </a:endParaRPr>
                     </a:p>
                     <a:p>
                       <a:pPr marL="0" marR="0" lvl="0" indent="0" algn="l" defTabSz="914400" rtl="0" eaLnBrk="1" fontAlgn="auto" latinLnBrk="0" hangingPunct="1">
@@ -35581,20 +35615,23 @@
                         <a:tabLst/>
                         <a:defRPr/>
                       </a:pPr>
-                      <a:endParaRPr kumimoji="0" lang="en-US" sz="1000" b="0" u="none" strike="noStrike" kern="1200" cap="none" spc="0" normalizeH="0" baseline="0" noProof="0">
-                        <a:ln>
-                          <a:noFill/>
-                        </a:ln>
-                        <a:solidFill>
-                          <a:prstClr val="black"/>
-                        </a:solidFill>
-                        <a:effectLst/>
-                        <a:uLnTx/>
-                        <a:uFillTx/>
-                      </a:endParaRPr>
+                      <a:r>
+                        <a:rPr kumimoji="0" lang="en-US" sz="1000" b="0" u="none" strike="noStrike" kern="1200" cap="none" spc="0" normalizeH="0" baseline="0" noProof="0" dirty="0">
+                          <a:ln>
+                            <a:noFill/>
+                          </a:ln>
+                          <a:solidFill>
+                            <a:prstClr val="black"/>
+                          </a:solidFill>
+                          <a:effectLst/>
+                          <a:uLnTx/>
+                          <a:uFillTx/>
+                        </a:rPr>
+                        <a:t>The time and effort involved in designing, rendering and fielding a questionnaire are significantly reduced.</a:t>
+                      </a:r>
                     </a:p>
                     <a:p>
-                      <a:endParaRPr lang="en-CA" sz="1000"/>
+                      <a:endParaRPr lang="en-CA" sz="1000" dirty="0"/>
                     </a:p>
                   </a:txBody>
                   <a:tcPr/>
@@ -35620,7 +35657,7 @@
                         <a:buChar char="•"/>
                       </a:pPr>
                       <a:r>
-                        <a:rPr lang="en-US" sz="1000" b="0" u="none" strike="noStrike" kern="1200">
+                        <a:rPr lang="en-US" sz="1000" b="0" u="none" strike="noStrike" kern="1200" dirty="0">
                           <a:solidFill>
                             <a:schemeClr val="tx1"/>
                           </a:solidFill>
@@ -35628,7 +35665,7 @@
                         <a:t>Assignment of full accountability for rendering  to a single </a:t>
                       </a:r>
                       <a:r>
-                        <a:rPr lang="en-US" sz="1000" b="0" u="none" strike="noStrike" kern="1200" err="1">
+                        <a:rPr lang="en-US" sz="1000" b="0" u="none" strike="noStrike" kern="1200" dirty="0" err="1">
                           <a:solidFill>
                             <a:schemeClr val="tx1"/>
                           </a:solidFill>
@@ -35636,7 +35673,7 @@
                         <a:t>centre</a:t>
                       </a:r>
                       <a:r>
-                        <a:rPr lang="en-US" sz="1000" b="0" u="none" strike="noStrike" kern="1200">
+                        <a:rPr lang="en-US" sz="1000" b="0" u="none" strike="noStrike" kern="1200" dirty="0">
                           <a:solidFill>
                             <a:schemeClr val="tx1"/>
                           </a:solidFill>
@@ -35663,7 +35700,7 @@
                         <a:defRPr/>
                       </a:pPr>
                       <a:r>
-                        <a:rPr kumimoji="0" lang="en-US" sz="1000" b="0" u="none" strike="noStrike" kern="1200" cap="none" spc="0" normalizeH="0" baseline="0" noProof="0">
+                        <a:rPr kumimoji="0" lang="en-US" sz="1000" b="0" u="none" strike="noStrike" kern="1200" cap="none" spc="0" normalizeH="0" baseline="0" noProof="0" dirty="0">
                           <a:ln>
                             <a:noFill/>
                           </a:ln>
@@ -35696,7 +35733,7 @@
                         <a:defRPr/>
                       </a:pPr>
                       <a:r>
-                        <a:rPr lang="en-US" sz="1000" b="0" u="none" strike="noStrike" kern="1200">
+                        <a:rPr lang="en-US" sz="1000" b="0" u="none" strike="noStrike" kern="1200" dirty="0">
                           <a:solidFill>
                             <a:schemeClr val="tx1"/>
                           </a:solidFill>
@@ -35723,7 +35760,7 @@
                         <a:defRPr/>
                       </a:pPr>
                       <a:r>
-                        <a:rPr lang="en-US" sz="1000" b="0" u="none" strike="noStrike" kern="1200">
+                        <a:rPr lang="en-US" sz="1000" b="0" u="none" strike="noStrike" kern="1200" dirty="0">
                           <a:solidFill>
                             <a:schemeClr val="tx1"/>
                           </a:solidFill>
@@ -35736,7 +35773,7 @@
                         <a:buFont typeface="Arial" panose="020B0604020202020204" pitchFamily="34" charset="0"/>
                         <a:buChar char="•"/>
                       </a:pPr>
-                      <a:endParaRPr lang="en-CA" sz="1000"/>
+                      <a:endParaRPr lang="en-CA" sz="1000" dirty="0"/>
                     </a:p>
                   </a:txBody>
                   <a:tcPr/>
@@ -35781,7 +35818,7 @@
                         <a:defRPr/>
                       </a:pPr>
                       <a:r>
-                        <a:rPr kumimoji="0" lang="en-US" sz="1000" b="0" u="none" strike="noStrike" kern="1200" cap="none" spc="0" normalizeH="0" baseline="0" noProof="0">
+                        <a:rPr kumimoji="0" lang="en-US" sz="1000" b="0" u="none" strike="noStrike" kern="1200" cap="none" spc="0" normalizeH="0" baseline="0" noProof="0" dirty="0">
                           <a:ln>
                             <a:noFill/>
                           </a:ln>
@@ -35813,7 +35850,7 @@
                         <a:tabLst/>
                         <a:defRPr/>
                       </a:pPr>
-                      <a:endParaRPr kumimoji="0" lang="en-US" sz="1000" b="0" u="none" strike="noStrike" kern="1200" cap="none" spc="0" normalizeH="0" baseline="0" noProof="0">
+                      <a:endParaRPr kumimoji="0" lang="en-US" sz="1000" b="0" u="none" strike="noStrike" kern="1200" cap="none" spc="0" normalizeH="0" baseline="0" noProof="0" dirty="0">
                         <a:ln>
                           <a:noFill/>
                         </a:ln>
@@ -35955,7 +35992,7 @@
                         <a:defRPr/>
                       </a:pPr>
                       <a:r>
-                        <a:rPr kumimoji="0" lang="en-US" sz="1000" b="0" u="none" strike="noStrike" kern="1200" cap="none" spc="0" normalizeH="0" baseline="0" noProof="0" err="1">
+                        <a:rPr kumimoji="0" lang="en-US" sz="1000" b="0" u="none" strike="noStrike" kern="1200" cap="none" spc="0" normalizeH="0" baseline="0" noProof="0" dirty="0" err="1">
                           <a:ln>
                             <a:noFill/>
                           </a:ln>
@@ -35969,7 +36006,7 @@
                         <a:t>Modernisation</a:t>
                       </a:r>
                       <a:r>
-                        <a:rPr kumimoji="0" lang="en-US" sz="1000" b="0" u="none" strike="noStrike" kern="1200" cap="none" spc="0" normalizeH="0" baseline="0" noProof="0">
+                        <a:rPr kumimoji="0" lang="en-US" sz="1000" b="0" u="none" strike="noStrike" kern="1200" cap="none" spc="0" normalizeH="0" baseline="0" noProof="0" dirty="0">
                           <a:ln>
                             <a:noFill/>
                           </a:ln>
@@ -36001,7 +36038,7 @@
                         <a:tabLst/>
                         <a:defRPr/>
                       </a:pPr>
-                      <a:endParaRPr kumimoji="0" lang="en-US" sz="1000" b="0" u="none" strike="noStrike" kern="1200" cap="none" spc="0" normalizeH="0" baseline="0" noProof="0">
+                      <a:endParaRPr kumimoji="0" lang="en-US" sz="1000" b="0" u="none" strike="noStrike" kern="1200" cap="none" spc="0" normalizeH="0" baseline="0" noProof="0" dirty="0">
                         <a:ln>
                           <a:noFill/>
                         </a:ln>
@@ -36032,7 +36069,7 @@
                         <a:defRPr/>
                       </a:pPr>
                       <a:r>
-                        <a:rPr kumimoji="0" lang="en-US" sz="1000" b="0" u="none" strike="noStrike" kern="1200" cap="none" spc="0" normalizeH="0" baseline="0" noProof="0">
+                        <a:rPr kumimoji="0" lang="en-US" sz="1000" b="0" u="none" strike="noStrike" kern="1200" cap="none" spc="0" normalizeH="0" baseline="0" noProof="0" dirty="0">
                           <a:ln>
                             <a:noFill/>
                           </a:ln>
@@ -36064,7 +36101,7 @@
                         <a:tabLst/>
                         <a:defRPr/>
                       </a:pPr>
-                      <a:endParaRPr kumimoji="0" lang="en-US" sz="1000" b="0" u="none" strike="noStrike" kern="1200" cap="none" spc="0" normalizeH="0" baseline="0" noProof="0">
+                      <a:endParaRPr kumimoji="0" lang="en-US" sz="1000" b="0" u="none" strike="noStrike" kern="1200" cap="none" spc="0" normalizeH="0" baseline="0" noProof="0" dirty="0">
                         <a:ln>
                           <a:noFill/>
                         </a:ln>
@@ -36095,7 +36132,7 @@
                         <a:defRPr/>
                       </a:pPr>
                       <a:r>
-                        <a:rPr kumimoji="0" lang="en-US" sz="1000" b="0" u="none" strike="noStrike" kern="1200" cap="none" spc="0" normalizeH="0" baseline="0" noProof="0">
+                        <a:rPr kumimoji="0" lang="en-US" sz="1000" b="0" u="none" strike="noStrike" kern="1200" cap="none" spc="0" normalizeH="0" baseline="0" noProof="0" dirty="0">
                           <a:ln>
                             <a:noFill/>
                           </a:ln>
@@ -36114,7 +36151,7 @@
                         <a:buFont typeface="Arial" panose="020B0604020202020204" pitchFamily="34" charset="0"/>
                         <a:buChar char="•"/>
                       </a:pPr>
-                      <a:endParaRPr lang="en-CA" sz="1000"/>
+                      <a:endParaRPr lang="en-CA" sz="1000" dirty="0"/>
                     </a:p>
                   </a:txBody>
                   <a:tcPr>
@@ -36200,7 +36237,7 @@
                         <a:defRPr/>
                       </a:pPr>
                       <a:r>
-                        <a:rPr kumimoji="0" lang="en-US" sz="1000" b="0" u="none" strike="noStrike" kern="1200" cap="none" spc="0" normalizeH="0" baseline="0" noProof="0">
+                        <a:rPr kumimoji="0" lang="en-US" sz="1000" b="0" u="none" strike="noStrike" kern="1200" cap="none" spc="0" normalizeH="0" baseline="0" noProof="0" dirty="0">
                           <a:ln>
                             <a:noFill/>
                           </a:ln>
@@ -36232,7 +36269,7 @@
                         <a:tabLst/>
                         <a:defRPr/>
                       </a:pPr>
-                      <a:endParaRPr kumimoji="0" lang="en-US" sz="1000" b="0" u="none" strike="noStrike" kern="1200" cap="none" spc="0" normalizeH="0" baseline="0" noProof="0">
+                      <a:endParaRPr kumimoji="0" lang="en-US" sz="1000" b="0" u="none" strike="noStrike" kern="1200" cap="none" spc="0" normalizeH="0" baseline="0" noProof="0" dirty="0">
                         <a:ln>
                           <a:noFill/>
                         </a:ln>
@@ -36263,7 +36300,7 @@
                         <a:defRPr/>
                       </a:pPr>
                       <a:r>
-                        <a:rPr kumimoji="0" lang="en-US" sz="1000" b="0" u="none" strike="noStrike" kern="1200" cap="none" spc="0" normalizeH="0" baseline="0" noProof="0">
+                        <a:rPr kumimoji="0" lang="en-US" sz="1000" b="0" u="none" strike="noStrike" kern="1200" cap="none" spc="0" normalizeH="0" baseline="0" noProof="0" dirty="0">
                           <a:ln>
                             <a:noFill/>
                           </a:ln>
@@ -36295,7 +36332,7 @@
                         <a:tabLst/>
                         <a:defRPr/>
                       </a:pPr>
-                      <a:endParaRPr kumimoji="0" lang="en-US" sz="1000" b="0" u="none" strike="noStrike" kern="1200" cap="none" spc="0" normalizeH="0" baseline="0" noProof="0">
+                      <a:endParaRPr kumimoji="0" lang="en-US" sz="1000" b="0" u="none" strike="noStrike" kern="1200" cap="none" spc="0" normalizeH="0" baseline="0" noProof="0" dirty="0">
                         <a:ln>
                           <a:noFill/>
                         </a:ln>
@@ -36326,7 +36363,7 @@
                         <a:defRPr/>
                       </a:pPr>
                       <a:r>
-                        <a:rPr kumimoji="0" lang="en-US" sz="1000" b="0" u="none" strike="noStrike" kern="1200" cap="none" spc="0" normalizeH="0" baseline="0" noProof="0">
+                        <a:rPr kumimoji="0" lang="en-US" sz="1000" b="0" u="none" strike="noStrike" kern="1200" cap="none" spc="0" normalizeH="0" baseline="0" noProof="0" dirty="0">
                           <a:ln>
                             <a:noFill/>
                           </a:ln>
@@ -36340,7 +36377,7 @@
                         <a:t>Implementation of forums to foster a culture of constant improvement and statistical </a:t>
                       </a:r>
                       <a:r>
-                        <a:rPr kumimoji="0" lang="en-US" sz="1000" b="0" u="none" strike="noStrike" kern="1200" cap="none" spc="0" normalizeH="0" baseline="0" noProof="0" err="1">
+                        <a:rPr kumimoji="0" lang="en-US" sz="1000" b="0" u="none" strike="noStrike" kern="1200" cap="none" spc="0" normalizeH="0" baseline="0" noProof="0" dirty="0" err="1">
                           <a:ln>
                             <a:noFill/>
                           </a:ln>
@@ -36354,7 +36391,7 @@
                         <a:t>rigour</a:t>
                       </a:r>
                       <a:r>
-                        <a:rPr kumimoji="0" lang="en-US" sz="1000" b="0" u="none" strike="noStrike" kern="1200" cap="none" spc="0" normalizeH="0" baseline="0" noProof="0">
+                        <a:rPr kumimoji="0" lang="en-US" sz="1000" b="0" u="none" strike="noStrike" kern="1200" cap="none" spc="0" normalizeH="0" baseline="0" noProof="0" dirty="0">
                           <a:ln>
                             <a:noFill/>
                           </a:ln>
@@ -36367,7 +36404,7 @@
                         </a:rPr>
                         <a:t> (4.4)</a:t>
                       </a:r>
-                      <a:endParaRPr lang="en-CA" sz="1000"/>
+                      <a:endParaRPr lang="en-CA" sz="1000" dirty="0"/>
                     </a:p>
                   </a:txBody>
                   <a:tcPr>

</xml_diff>